<commit_message>
Làm lại giao diện: thanh bên tối, đăng nhập chia đôi, thẻ số liệu và biểu đồ
- Hệ thống thiết kế mới (Inter, lucide-react), nút/ô nhập/bảng/huy hiệu đồng nhất
- Thanh bên có biểu tượng, thanh trên có avatar, hiển thị tốt trên điện thoại
- Tổng quan: thẻ số liệu, vòng tròn chuyên cần/điểm, biểu đồ cột học phí
- Điểm danh bằng nút chọn nhanh, nút "Tất cả có mặt", tab dạng segmented
- Khung chờ (skeleton) và trạng thái rỗng thay cho chữ thuần
- Cập nhật ảnh chụp trong docs và bài thuyết trình

Co-Authored-By: Claude Sonnet 5.5 <noreply@anthropic.com>
</commit_message>
<xml_diff>
--- a/docs/HKII-ThuyetTrinh.pptx
+++ b/docs/HKII-ThuyetTrinh.pptx
@@ -123,14 +123,14 @@
   <p:extLst>
     <p:ext uri="{521415D9-36F7-43E2-AB2F-B90AF26B5E84}">
       <p14:sectionLst xmlns:p14="http://schemas.microsoft.com/office/powerpoint/2010/main">
-        <p14:section name="Mở đầu" id="{39ac3c42-9c30-f9e7-276f-41e375a99c25}">
+        <p14:section name="Mở đầu" id="{98476853-b0a5-0cd2-472f-12fa1539789e}">
           <p14:sldIdLst>
             <p14:sldId id="256"/>
             <p14:sldId id="257"/>
             <p14:sldId id="258"/>
           </p14:sldIdLst>
         </p14:section>
-        <p14:section name="Thiết kế" id="{d9e3853e-e534-d3fe-091b-299d485bb566}">
+        <p14:section name="Thiết kế" id="{096d3582-fba0-5802-aa3e-b8ce080654b1}">
           <p14:sldIdLst>
             <p14:sldId id="259"/>
             <p14:sldId id="260"/>
@@ -138,7 +138,7 @@
             <p14:sldId id="262"/>
           </p14:sldIdLst>
         </p14:section>
-        <p14:section name="Demo" id="{fb5ba500-5260-1e08-ceb1-db8e99f2c521}">
+        <p14:section name="Demo" id="{a5870ed6-b879-bea3-1490-8997737d50b3}">
           <p14:sldIdLst>
             <p14:sldId id="263"/>
             <p14:sldId id="264"/>
@@ -148,13 +148,13 @@
             <p14:sldId id="268"/>
           </p14:sldIdLst>
         </p14:section>
-        <p14:section name="Triển khai" id="{bf68d8b9-d8be-2d1e-3dc3-2cfab068cf63}">
+        <p14:section name="Triển khai" id="{c96c8993-eb92-93ed-d52e-9737d73b33b9}">
           <p14:sldIdLst>
             <p14:sldId id="269"/>
             <p14:sldId id="270"/>
           </p14:sldIdLst>
         </p14:section>
-        <p14:section name="Kết luận" id="{fc031b4f-bdd5-0093-fcf9-a38133d9c441}">
+        <p14:section name="Kết luận" id="{76423387-1dcd-8502-273a-78314aa5791d}">
           <p14:sldIdLst>
             <p14:sldId id="271"/>
             <p14:sldId id="272"/>

</xml_diff>